<commit_message>
Auto bot updater Datasphere Course
</commit_message>
<xml_diff>
--- a/Day 14/SAP Build Training Day 14.pptx
+++ b/Day 14/SAP Build Training Day 14.pptx
@@ -5,20 +5,21 @@
     <p:sldMasterId id="2147483648" r:id="rId1"/>
   </p:sldMasterIdLst>
   <p:notesMasterIdLst>
-    <p:notesMasterId r:id="rId10"/>
+    <p:notesMasterId r:id="rId11"/>
   </p:notesMasterIdLst>
   <p:handoutMasterIdLst>
-    <p:handoutMasterId r:id="rId11"/>
+    <p:handoutMasterId r:id="rId12"/>
   </p:handoutMasterIdLst>
   <p:sldIdLst>
     <p:sldId id="256" r:id="rId2"/>
     <p:sldId id="494" r:id="rId3"/>
     <p:sldId id="265" r:id="rId4"/>
-    <p:sldId id="382" r:id="rId5"/>
-    <p:sldId id="383" r:id="rId6"/>
-    <p:sldId id="495" r:id="rId7"/>
-    <p:sldId id="496" r:id="rId8"/>
-    <p:sldId id="497" r:id="rId9"/>
+    <p:sldId id="381" r:id="rId5"/>
+    <p:sldId id="382" r:id="rId6"/>
+    <p:sldId id="383" r:id="rId7"/>
+    <p:sldId id="495" r:id="rId8"/>
+    <p:sldId id="496" r:id="rId9"/>
+    <p:sldId id="497" r:id="rId10"/>
   </p:sldIdLst>
   <p:sldSz cx="9144000" cy="5143500" type="screen16x9"/>
   <p:notesSz cx="6858000" cy="9144000"/>
@@ -232,7 +233,7 @@
           <a:p>
             <a:fld id="{74CD1819-8EAB-4094-BBB1-E11C3AABA846}" type="datetimeFigureOut">
               <a:rPr lang="en-US" smtClean="0"/>
-              <a:t>7/26/2025</a:t>
+              <a:t>7/29/2025</a:t>
             </a:fld>
             <a:endParaRPr lang="en-US"/>
           </a:p>
@@ -313,6 +314,40 @@
   </p:cSld>
   <p:clrMap bg1="lt1" tx1="dk1" bg2="lt2" tx2="dk2" accent1="accent1" accent2="accent2" accent3="accent3" accent4="accent4" accent5="accent5" accent6="accent6" hlink="hlink" folHlink="folHlink"/>
 </p:handoutMaster>
+</file>
+
+<file path=ppt/ink/ink1.xml><?xml version="1.0" encoding="utf-8"?>
+<inkml:ink xmlns:inkml="http://www.w3.org/2003/InkML">
+  <inkml:definitions>
+    <inkml:context xml:id="ctx0">
+      <inkml:inkSource xml:id="inkSrc0">
+        <inkml:traceFormat>
+          <inkml:channel name="X" type="integer" max="2560" units="cm"/>
+          <inkml:channel name="Y" type="integer" max="1600" units="cm"/>
+          <inkml:channel name="T" type="integer" max="2.14748E9" units="dev"/>
+        </inkml:traceFormat>
+        <inkml:channelProperties>
+          <inkml:channelProperty channel="X" name="resolution" value="74.2029" units="1/cm"/>
+          <inkml:channelProperty channel="Y" name="resolution" value="74.4186" units="1/cm"/>
+          <inkml:channelProperty channel="T" name="resolution" value="1" units="1/dev"/>
+        </inkml:channelProperties>
+      </inkml:inkSource>
+      <inkml:timestamp xml:id="ts0" timeString="2025-02-04T13:48:17.697"/>
+    </inkml:context>
+    <inkml:brush xml:id="br0">
+      <inkml:brushProperty name="width" value="0.05292" units="cm"/>
+      <inkml:brushProperty name="height" value="0.05292" units="cm"/>
+      <inkml:brushProperty name="color" value="#FF0000"/>
+    </inkml:brush>
+  </inkml:definitions>
+  <inkml:trace contextRef="#ctx0" brushRef="#br0">16976 6499 0</inkml:trace>
+  <inkml:trace contextRef="#ctx0" brushRef="#br0" timeOffset="1087.56">16976 6489 0</inkml:trace>
+  <inkml:trace contextRef="#ctx0" brushRef="#br0" timeOffset="1613.75">19080 6668 0</inkml:trace>
+  <inkml:trace contextRef="#ctx0" brushRef="#br0" timeOffset="8430.07">19090 11827 0</inkml:trace>
+  <inkml:trace contextRef="#ctx0" brushRef="#br0" timeOffset="8899.6">19100 11787 0</inkml:trace>
+  <inkml:trace contextRef="#ctx0" brushRef="#br0" timeOffset="9117.84">19149 11787 0</inkml:trace>
+  <inkml:trace contextRef="#ctx0" brushRef="#br0" timeOffset="20662.75">17115 8801 0</inkml:trace>
+</inkml:ink>
 </file>
 
 <file path=ppt/notesMasters/notesMaster1.xml><?xml version="1.0" encoding="utf-8"?>
@@ -397,7 +432,7 @@
           <a:p>
             <a:fld id="{D976A73D-237B-4034-AB8C-962174A8D351}" type="datetimeFigureOut">
               <a:rPr lang="en-US" smtClean="0"/>
-              <a:t>7/26/2025</a:t>
+              <a:t>7/29/2025</a:t>
             </a:fld>
             <a:endParaRPr lang="en-US"/>
           </a:p>
@@ -862,7 +897,7 @@
                 <a:tabLst/>
                 <a:defRPr/>
               </a:pPr>
-              <a:t>8</a:t>
+              <a:t>9</a:t>
             </a:fld>
             <a:endParaRPr kumimoji="0" lang="en-US" sz="1200" b="0" i="0" u="none" strike="noStrike" kern="1200" cap="none" spc="0" normalizeH="0" baseline="0" noProof="0">
               <a:ln>
@@ -1099,7 +1134,7 @@
             <a:fld id="{1D8BD707-D9CF-40AE-B4C6-C98DA3205C09}" type="datetimeFigureOut">
               <a:rPr lang="en-US" smtClean="0"/>
               <a:pPr/>
-              <a:t>7/26/2025</a:t>
+              <a:t>7/29/2025</a:t>
             </a:fld>
             <a:endParaRPr lang="en-US"/>
           </a:p>
@@ -4462,7 +4497,7 @@
           <a:p>
             <a:fld id="{940CB006-912F-44E1-9560-9CBFEBE946EF}" type="datetime4">
               <a:rPr lang="en-US" smtClean="0"/>
-              <a:t>July 26, 2025</a:t>
+              <a:t>July 29, 2025</a:t>
             </a:fld>
             <a:endParaRPr lang="en-US"/>
           </a:p>
@@ -8365,6 +8400,234 @@
         <p:cNvPr id="1" name="">
           <a:extLst>
             <a:ext uri="{FF2B5EF4-FFF2-40B4-BE49-F238E27FC236}">
+              <a16:creationId xmlns:a16="http://schemas.microsoft.com/office/drawing/2014/main" id="{0C661E7E-78B8-DEEA-19CD-A6C24052FABB}"/>
+            </a:ext>
+          </a:extLst>
+        </p:cNvPr>
+        <p:cNvGrpSpPr/>
+        <p:nvPr/>
+      </p:nvGrpSpPr>
+      <p:grpSpPr>
+        <a:xfrm>
+          <a:off x="0" y="0"/>
+          <a:ext cx="0" cy="0"/>
+          <a:chOff x="0" y="0"/>
+          <a:chExt cx="0" cy="0"/>
+        </a:xfrm>
+      </p:grpSpPr>
+      <p:sp>
+        <p:nvSpPr>
+          <p:cNvPr id="3" name="Footer Placeholder 2">
+            <a:extLst>
+              <a:ext uri="{FF2B5EF4-FFF2-40B4-BE49-F238E27FC236}">
+                <a16:creationId xmlns:a16="http://schemas.microsoft.com/office/drawing/2014/main" id="{543EA3D0-88DA-29C8-AF5E-2C60DB793631}"/>
+              </a:ext>
+            </a:extLst>
+          </p:cNvPr>
+          <p:cNvSpPr>
+            <a:spLocks noGrp="1"/>
+          </p:cNvSpPr>
+          <p:nvPr>
+            <p:ph type="ftr" sz="quarter" idx="11"/>
+          </p:nvPr>
+        </p:nvSpPr>
+        <p:spPr/>
+        <p:txBody>
+          <a:bodyPr/>
+          <a:lstStyle/>
+          <a:p>
+            <a:r>
+              <a:rPr lang="en-US" dirty="0"/>
+              <a:t>www.anubhavtrainings.com</a:t>
+            </a:r>
+          </a:p>
+        </p:txBody>
+      </p:sp>
+      <p:sp>
+        <p:nvSpPr>
+          <p:cNvPr id="4" name="Slide Number Placeholder 3">
+            <a:extLst>
+              <a:ext uri="{FF2B5EF4-FFF2-40B4-BE49-F238E27FC236}">
+                <a16:creationId xmlns:a16="http://schemas.microsoft.com/office/drawing/2014/main" id="{02D999FF-D688-D4BE-0D41-6DF253CCB41E}"/>
+              </a:ext>
+            </a:extLst>
+          </p:cNvPr>
+          <p:cNvSpPr>
+            <a:spLocks noGrp="1"/>
+          </p:cNvSpPr>
+          <p:nvPr>
+            <p:ph type="sldNum" sz="quarter" idx="12"/>
+          </p:nvPr>
+        </p:nvSpPr>
+        <p:spPr>
+          <a:xfrm>
+            <a:off x="152400" y="4781550"/>
+            <a:ext cx="457200" cy="273844"/>
+          </a:xfrm>
+        </p:spPr>
+        <p:txBody>
+          <a:bodyPr/>
+          <a:lstStyle/>
+          <a:p>
+            <a:fld id="{B6F15528-21DE-4FAA-801E-634DDDAF4B2B}" type="slidenum">
+              <a:rPr lang="en-US" smtClean="0"/>
+              <a:pPr/>
+              <a:t>4</a:t>
+            </a:fld>
+            <a:endParaRPr lang="en-US" dirty="0"/>
+          </a:p>
+        </p:txBody>
+      </p:sp>
+      <p:sp>
+        <p:nvSpPr>
+          <p:cNvPr id="5" name="Title 4">
+            <a:extLst>
+              <a:ext uri="{FF2B5EF4-FFF2-40B4-BE49-F238E27FC236}">
+                <a16:creationId xmlns:a16="http://schemas.microsoft.com/office/drawing/2014/main" id="{5B5FDED6-960C-CC14-A9DB-D4442C80D253}"/>
+              </a:ext>
+            </a:extLst>
+          </p:cNvPr>
+          <p:cNvSpPr>
+            <a:spLocks noGrp="1"/>
+          </p:cNvSpPr>
+          <p:nvPr>
+            <p:ph type="title"/>
+          </p:nvPr>
+        </p:nvSpPr>
+        <p:spPr>
+          <a:xfrm>
+            <a:off x="76200" y="133350"/>
+            <a:ext cx="8229600" cy="533401"/>
+          </a:xfrm>
+        </p:spPr>
+        <p:txBody>
+          <a:bodyPr/>
+          <a:lstStyle/>
+          <a:p>
+            <a:r>
+              <a:rPr lang="en-IN" sz="2500" dirty="0"/>
+              <a:t>Automation Flow design by Anubhav</a:t>
+            </a:r>
+            <a:endParaRPr lang="en-IN" sz="2500" dirty="0">
+              <a:latin typeface="Cooper Black" panose="0208090404030B020404" pitchFamily="18" charset="0"/>
+            </a:endParaRPr>
+          </a:p>
+        </p:txBody>
+      </p:sp>
+      <p:pic>
+        <p:nvPicPr>
+          <p:cNvPr id="7" name="Picture 6">
+            <a:extLst>
+              <a:ext uri="{FF2B5EF4-FFF2-40B4-BE49-F238E27FC236}">
+                <a16:creationId xmlns:a16="http://schemas.microsoft.com/office/drawing/2014/main" id="{36A83D08-A321-5B5F-7E81-718E8056953E}"/>
+              </a:ext>
+            </a:extLst>
+          </p:cNvPr>
+          <p:cNvPicPr>
+            <a:picLocks noChangeAspect="1"/>
+          </p:cNvPicPr>
+          <p:nvPr/>
+        </p:nvPicPr>
+        <p:blipFill>
+          <a:blip r:embed="rId2"/>
+          <a:stretch>
+            <a:fillRect/>
+          </a:stretch>
+        </p:blipFill>
+        <p:spPr>
+          <a:xfrm>
+            <a:off x="3276600" y="675858"/>
+            <a:ext cx="2447330" cy="4400550"/>
+          </a:xfrm>
+          <a:prstGeom prst="rect">
+            <a:avLst/>
+          </a:prstGeom>
+        </p:spPr>
+      </p:pic>
+      <mc:AlternateContent xmlns:mc="http://schemas.openxmlformats.org/markup-compatibility/2006" xmlns:p14="http://schemas.microsoft.com/office/powerpoint/2010/main">
+        <mc:Choice Requires="p14">
+          <p:contentPart p14:bwMode="auto" r:id="rId3">
+            <p14:nvContentPartPr>
+              <p14:cNvPr id="8" name="Ink 7">
+                <a:extLst>
+                  <a:ext uri="{FF2B5EF4-FFF2-40B4-BE49-F238E27FC236}">
+                    <a16:creationId xmlns:a16="http://schemas.microsoft.com/office/drawing/2014/main" id="{2A17112A-B879-1075-568B-B6389385BC82}"/>
+                  </a:ext>
+                </a:extLst>
+              </p14:cNvPr>
+              <p14:cNvContentPartPr/>
+              <p14:nvPr/>
+            </p14:nvContentPartPr>
+            <p14:xfrm>
+              <a:off x="6111360" y="2336040"/>
+              <a:ext cx="782640" cy="1922040"/>
+            </p14:xfrm>
+          </p:contentPart>
+        </mc:Choice>
+        <mc:Fallback xmlns="">
+          <p:pic>
+            <p:nvPicPr>
+              <p:cNvPr id="8" name="Ink 7">
+                <a:extLst>
+                  <a:ext uri="{FF2B5EF4-FFF2-40B4-BE49-F238E27FC236}">
+                    <a16:creationId xmlns:a16="http://schemas.microsoft.com/office/drawing/2014/main" id="{2A17112A-B879-1075-568B-B6389385BC82}"/>
+                  </a:ext>
+                </a:extLst>
+              </p:cNvPr>
+              <p:cNvPicPr/>
+              <p:nvPr/>
+            </p:nvPicPr>
+            <p:blipFill>
+              <a:blip r:embed="rId4"/>
+              <a:stretch>
+                <a:fillRect/>
+              </a:stretch>
+            </p:blipFill>
+            <p:spPr>
+              <a:xfrm>
+                <a:off x="6102000" y="2326680"/>
+                <a:ext cx="801360" cy="1940760"/>
+              </a:xfrm>
+              <a:prstGeom prst="rect">
+                <a:avLst/>
+              </a:prstGeom>
+            </p:spPr>
+          </p:pic>
+        </mc:Fallback>
+      </mc:AlternateContent>
+    </p:spTree>
+    <p:extLst>
+      <p:ext uri="{BB962C8B-B14F-4D97-AF65-F5344CB8AC3E}">
+        <p14:creationId xmlns:p14="http://schemas.microsoft.com/office/powerpoint/2010/main" val="1222834871"/>
+      </p:ext>
+    </p:extLst>
+  </p:cSld>
+  <p:clrMapOvr>
+    <a:masterClrMapping/>
+  </p:clrMapOvr>
+  <mc:AlternateContent xmlns:mc="http://schemas.openxmlformats.org/markup-compatibility/2006" xmlns:p14="http://schemas.microsoft.com/office/powerpoint/2010/main">
+    <mc:Choice Requires="p14">
+      <p:transition spd="med" p14:dur="700">
+        <p:fade/>
+      </p:transition>
+    </mc:Choice>
+    <mc:Fallback xmlns="">
+      <p:transition spd="med">
+        <p:fade/>
+      </p:transition>
+    </mc:Fallback>
+  </mc:AlternateContent>
+</p:sld>
+</file>
+
+<file path=ppt/slides/slide5.xml><?xml version="1.0" encoding="utf-8"?>
+<p:sld xmlns:a="http://schemas.openxmlformats.org/drawingml/2006/main" xmlns:r="http://schemas.openxmlformats.org/officeDocument/2006/relationships" xmlns:p="http://schemas.openxmlformats.org/presentationml/2006/main">
+  <p:cSld>
+    <p:spTree>
+      <p:nvGrpSpPr>
+        <p:cNvPr id="1" name="">
+          <a:extLst>
+            <a:ext uri="{FF2B5EF4-FFF2-40B4-BE49-F238E27FC236}">
               <a16:creationId xmlns:a16="http://schemas.microsoft.com/office/drawing/2014/main" id="{D572AD34-F317-4B32-971A-5D212E8ECD47}"/>
             </a:ext>
           </a:extLst>
@@ -8437,7 +8700,7 @@
             <a:fld id="{B6F15528-21DE-4FAA-801E-634DDDAF4B2B}" type="slidenum">
               <a:rPr lang="en-US" smtClean="0"/>
               <a:pPr/>
-              <a:t>4</a:t>
+              <a:t>5</a:t>
             </a:fld>
             <a:endParaRPr lang="en-US" dirty="0"/>
           </a:p>
@@ -8646,7 +8909,7 @@
 </p:sld>
 </file>
 
-<file path=ppt/slides/slide5.xml><?xml version="1.0" encoding="utf-8"?>
+<file path=ppt/slides/slide6.xml><?xml version="1.0" encoding="utf-8"?>
 <p:sld xmlns:a="http://schemas.openxmlformats.org/drawingml/2006/main" xmlns:r="http://schemas.openxmlformats.org/officeDocument/2006/relationships" xmlns:p="http://schemas.openxmlformats.org/presentationml/2006/main">
   <p:cSld>
     <p:spTree>
@@ -8799,7 +9062,7 @@
                   <a:spcPts val="600"/>
                 </a:spcAft>
               </a:pPr>
-              <a:t>5</a:t>
+              <a:t>6</a:t>
             </a:fld>
             <a:endParaRPr lang="en-US"/>
           </a:p>
@@ -8931,7 +9194,7 @@
 </p:sld>
 </file>
 
-<file path=ppt/slides/slide6.xml><?xml version="1.0" encoding="utf-8"?>
+<file path=ppt/slides/slide7.xml><?xml version="1.0" encoding="utf-8"?>
 <p:sld xmlns:a="http://schemas.openxmlformats.org/drawingml/2006/main" xmlns:r="http://schemas.openxmlformats.org/officeDocument/2006/relationships" xmlns:p="http://schemas.openxmlformats.org/presentationml/2006/main">
   <p:cSld>
     <p:spTree>
@@ -9925,7 +10188,7 @@
 </p:sld>
 </file>
 
-<file path=ppt/slides/slide7.xml><?xml version="1.0" encoding="utf-8"?>
+<file path=ppt/slides/slide8.xml><?xml version="1.0" encoding="utf-8"?>
 <p:sld xmlns:a="http://schemas.openxmlformats.org/drawingml/2006/main" xmlns:r="http://schemas.openxmlformats.org/officeDocument/2006/relationships" xmlns:p="http://schemas.openxmlformats.org/presentationml/2006/main">
   <p:cSld>
     <p:spTree>
@@ -11465,7 +11728,7 @@
 </p:sld>
 </file>
 
-<file path=ppt/slides/slide8.xml><?xml version="1.0" encoding="utf-8"?>
+<file path=ppt/slides/slide9.xml><?xml version="1.0" encoding="utf-8"?>
 <p:sld xmlns:a="http://schemas.openxmlformats.org/drawingml/2006/main" xmlns:r="http://schemas.openxmlformats.org/officeDocument/2006/relationships" xmlns:p="http://schemas.openxmlformats.org/presentationml/2006/main">
   <p:cSld>
     <p:spTree>

</xml_diff>